<commit_message>
feat(admin): fichas administrativas y cierre de deuda técnica de seguridad
- Fichas de equipo y usuario con renombre sincronizado y auditoría.
- Login con email verificado, email inmutable para admin y jugador.
- Baja lógica, cambio de rol transaccional y confirmación para promover admin.
- Suplantación con POST+CSRF, sin auto-suplantación ni otros administradores.
- Migraciones 008-010, escudos de equipos y pruebas unitarias/E2E.
- Documentación y comandos de prueba actualizados (XAMPP y Docker).
</commit_message>
<xml_diff>
--- a/presentacion/ASCEND_Defensa.pptx
+++ b/presentacion/ASCEND_Defensa.pptx
@@ -2250,7 +2250,7 @@
                 <a:latin typeface="Segoe UI"/>
                 <a:ea typeface="Segoe UI"/>
               </a:rPr>
-              <a:t>41 tablas, 6 migraciones, seed QA, respaldo y replicación.</a:t>
+              <a:t>41 tablas, 7 migraciones, seed QA, respaldo y replicación.</a:t>
             </a:r>
           </a:p>
         </p:txBody>
@@ -9503,7 +9503,7 @@
                 <a:latin typeface="Segoe UI"/>
                 <a:ea typeface="Segoe UI"/>
               </a:rPr>
-              <a:t>41 tablas, 6 migraciones y un seed que permite probar todos los formatos.</a:t>
+              <a:t>41 tablas, 7 migraciones y un seed que permite probar todos los formatos.</a:t>
             </a:r>
           </a:p>
         </p:txBody>

</xml_diff>